<commit_message>
add new repaired version
</commit_message>
<xml_diff>
--- a/test/basic-test.pptx
+++ b/test/basic-test.pptx
@@ -10,8 +10,102 @@
     <p:sldId id="259" r:id="rId4"/>
     <p:sldId id="260" r:id="rId5"/>
   </p:sldIdLst>
-  <p:sldSz cx="9144000" cy="6858000"/>
-  <p:notesSz cx="6858000" cy="9144000"/>
+  <p:sldSz cx="9144000" cy="6858000" type="screen4x3"/>
+  <p:defaultTextStyle>
+    <a:defPPr>
+      <a:defRPr lang="en-US"/>
+    </a:defPPr>
+    <a:lvl1pPr marL="0" algn="l" defTabSz="914400" rtl="0" eaLnBrk="1" latinLnBrk="0" hangingPunct="1">
+      <a:defRPr sz="1800" kern="1200">
+        <a:solidFill>
+          <a:schemeClr val="tx1"/>
+        </a:solidFill>
+        <a:latin typeface="+mn-lt"/>
+        <a:ea typeface="+mn-ea"/>
+        <a:cs typeface="+mn-cs"/>
+      </a:defRPr>
+    </a:lvl1pPr>
+    <a:lvl2pPr marL="457200" algn="l" defTabSz="914400" rtl="0" eaLnBrk="1" latinLnBrk="0" hangingPunct="1">
+      <a:defRPr sz="1800" kern="1200">
+        <a:solidFill>
+          <a:schemeClr val="tx1"/>
+        </a:solidFill>
+        <a:latin typeface="+mn-lt"/>
+        <a:ea typeface="+mn-ea"/>
+        <a:cs typeface="+mn-cs"/>
+      </a:defRPr>
+    </a:lvl2pPr>
+    <a:lvl3pPr marL="914400" algn="l" defTabSz="914400" rtl="0" eaLnBrk="1" latinLnBrk="0" hangingPunct="1">
+      <a:defRPr sz="1800" kern="1200">
+        <a:solidFill>
+          <a:schemeClr val="tx1"/>
+        </a:solidFill>
+        <a:latin typeface="+mn-lt"/>
+        <a:ea typeface="+mn-ea"/>
+        <a:cs typeface="+mn-cs"/>
+      </a:defRPr>
+    </a:lvl3pPr>
+    <a:lvl4pPr marL="1371600" algn="l" defTabSz="914400" rtl="0" eaLnBrk="1" latinLnBrk="0" hangingPunct="1">
+      <a:defRPr sz="1800" kern="1200">
+        <a:solidFill>
+          <a:schemeClr val="tx1"/>
+        </a:solidFill>
+        <a:latin typeface="+mn-lt"/>
+        <a:ea typeface="+mn-ea"/>
+        <a:cs typeface="+mn-cs"/>
+      </a:defRPr>
+    </a:lvl4pPr>
+    <a:lvl5pPr marL="1828800" algn="l" defTabSz="914400" rtl="0" eaLnBrk="1" latinLnBrk="0" hangingPunct="1">
+      <a:defRPr sz="1800" kern="1200">
+        <a:solidFill>
+          <a:schemeClr val="tx1"/>
+        </a:solidFill>
+        <a:latin typeface="+mn-lt"/>
+        <a:ea typeface="+mn-ea"/>
+        <a:cs typeface="+mn-cs"/>
+      </a:defRPr>
+    </a:lvl5pPr>
+    <a:lvl6pPr marL="2286000" algn="l" defTabSz="914400" rtl="0" eaLnBrk="1" latinLnBrk="0" hangingPunct="1">
+      <a:defRPr sz="1800" kern="1200">
+        <a:solidFill>
+          <a:schemeClr val="tx1"/>
+        </a:solidFill>
+        <a:latin typeface="+mn-lt"/>
+        <a:ea typeface="+mn-ea"/>
+        <a:cs typeface="+mn-cs"/>
+      </a:defRPr>
+    </a:lvl6pPr>
+    <a:lvl7pPr marL="2743200" algn="l" defTabSz="914400" rtl="0" eaLnBrk="1" latinLnBrk="0" hangingPunct="1">
+      <a:defRPr sz="1800" kern="1200">
+        <a:solidFill>
+          <a:schemeClr val="tx1"/>
+        </a:solidFill>
+        <a:latin typeface="+mn-lt"/>
+        <a:ea typeface="+mn-ea"/>
+        <a:cs typeface="+mn-cs"/>
+      </a:defRPr>
+    </a:lvl7pPr>
+    <a:lvl8pPr marL="3200400" algn="l" defTabSz="914400" rtl="0" eaLnBrk="1" latinLnBrk="0" hangingPunct="1">
+      <a:defRPr sz="1800" kern="1200">
+        <a:solidFill>
+          <a:schemeClr val="tx1"/>
+        </a:solidFill>
+        <a:latin typeface="+mn-lt"/>
+        <a:ea typeface="+mn-ea"/>
+        <a:cs typeface="+mn-cs"/>
+      </a:defRPr>
+    </a:lvl8pPr>
+    <a:lvl9pPr marL="3657600" algn="l" defTabSz="914400" rtl="0" eaLnBrk="1" latinLnBrk="0" hangingPunct="1">
+      <a:defRPr sz="1800" kern="1200">
+        <a:solidFill>
+          <a:schemeClr val="tx1"/>
+        </a:solidFill>
+        <a:latin typeface="+mn-lt"/>
+        <a:ea typeface="+mn-ea"/>
+        <a:cs typeface="+mn-cs"/>
+      </a:defRPr>
+    </a:lvl9pPr>
+  </p:defaultTextStyle>
 </p:presentation>
 </file>
 

</xml_diff>

<commit_message>
Powerpoint opens test file with 'repaired' warning
</commit_message>
<xml_diff>
--- a/test/basic-test.pptx
+++ b/test/basic-test.pptx
@@ -160,6 +160,9 @@
     </p:spTree>
   </p:cSld>
   <p:clrMap bg1="lt1" tx1="dk1" bg2="lt2" tx2="dk2" accent1="accent1" accent2="accent2" accent3="accent3" accent4="accent4" accent5="accent5" accent6="accent6" hlink="hlink" folHlink="folHlink"/>
+  <p:sldLayoutIdLst>
+    <p:sldLayoutId id="2147483649" r:id="rId1"/>
+  </p:sldLayoutIdLst>
   <p:txStyles>
     <p:titleStyle>
       <a:lvl1pPr algn="l" defTabSz="914400" rtl="0" eaLnBrk="1" latinLnBrk="0" hangingPunct="1">
@@ -440,9 +443,6 @@
       </a:lvl9pPr>
     </p:otherStyle>
   </p:txStyles>
-  <p:sldLayoutIdLst>
-    <p:sldLayoutId id="2147483649" r:id="rId1"/>
-  </p:sldLayoutIdLst>
 </p:sldMaster>
 </file>
 

</xml_diff>

<commit_message>
still repaired by powerpoint
</commit_message>
<xml_diff>
--- a/test/basic-test.pptx
+++ b/test/basic-test.pptx
@@ -852,11 +852,105 @@
         <a:latin typeface="Calibri Light" panose="020F0302020204030204"/>
         <a:ea typeface=""/>
         <a:cs typeface=""/>
+        <a:font script="Jpan" typeface="游ゴシック Light"/>
+        <a:font script="Hang" typeface="맑은 고딕"/>
+        <a:font script="Hans" typeface="等线 Light"/>
+        <a:font script="Hant" typeface="新細明體"/>
+        <a:font script="Arab" typeface="Times New Roman"/>
+        <a:font script="Hebr" typeface="Times New Roman"/>
+        <a:font script="Thai" typeface="Angsana New"/>
+        <a:font script="Ethi" typeface="Nyala"/>
+        <a:font script="Beng" typeface="Vrinda"/>
+        <a:font script="Gujr" typeface="Shruti"/>
+        <a:font script="Khmr" typeface="MoolBoran"/>
+        <a:font script="Knda" typeface="Tunga"/>
+        <a:font script="Guru" typeface="Raavi"/>
+        <a:font script="Cans" typeface="Euphemia"/>
+        <a:font script="Cher" typeface="Plantagenet Cherokee"/>
+        <a:font script="Yiii" typeface="Microsoft Yi Baiti"/>
+        <a:font script="Tibt" typeface="Microsoft Himalaya"/>
+        <a:font script="Thaa" typeface="MV Boli"/>
+        <a:font script="Deva" typeface="Mangal"/>
+        <a:font script="Telu" typeface="Gautami"/>
+        <a:font script="Taml" typeface="Latha"/>
+        <a:font script="Syrc" typeface="Estrangelo Edessa"/>
+        <a:font script="Orya" typeface="Kalinga"/>
+        <a:font script="Mlym" typeface="Kartika"/>
+        <a:font script="Laoo" typeface="DokChampa"/>
+        <a:font script="Sinh" typeface="Iskoola Pota"/>
+        <a:font script="Mong" typeface="Mongolian Baiti"/>
+        <a:font script="Viet" typeface="Times New Roman"/>
+        <a:font script="Uigh" typeface="Microsoft Uighur"/>
+        <a:font script="Geor" typeface="Sylfaen"/>
+        <a:font script="Armn" typeface="Arial"/>
+        <a:font script="Bugi" typeface="Leelawadee UI"/>
+        <a:font script="Bopo" typeface="Microsoft JhengHei"/>
+        <a:font script="Java" typeface="Javanese Text"/>
+        <a:font script="Lisu" typeface="Segoe UI"/>
+        <a:font script="Mymr" typeface="Myanmar Text"/>
+        <a:font script="Nkoo" typeface="Ebrima"/>
+        <a:font script="Olck" typeface="Nirmala UI"/>
+        <a:font script="Osma" typeface="Ebrima"/>
+        <a:font script="Phag" typeface="Phagspa"/>
+        <a:font script="Syrn" typeface="Estrangelo Edessa"/>
+        <a:font script="Syrj" typeface="Estrangelo Edessa"/>
+        <a:font script="Syre" typeface="Estrangelo Edessa"/>
+        <a:font script="Sora" typeface="Nirmala UI"/>
+        <a:font script="Tale" typeface="Microsoft Tai Le"/>
+        <a:font script="Talu" typeface="Microsoft New Tai Lue"/>
+        <a:font script="Tfng" typeface="Ebrima"/>
       </a:majorFont>
       <a:minorFont>
         <a:latin typeface="Calibri" panose="020F0502020204030204"/>
         <a:ea typeface=""/>
         <a:cs typeface=""/>
+        <a:font script="Jpan" typeface="游ゴシック"/>
+        <a:font script="Hang" typeface="맑은 고딕"/>
+        <a:font script="Hans" typeface="等线"/>
+        <a:font script="Hant" typeface="新細明體"/>
+        <a:font script="Arab" typeface="Arial"/>
+        <a:font script="Hebr" typeface="Arial"/>
+        <a:font script="Thai" typeface="Cordia New"/>
+        <a:font script="Ethi" typeface="Nyala"/>
+        <a:font script="Beng" typeface="Vrinda"/>
+        <a:font script="Gujr" typeface="Shruti"/>
+        <a:font script="Khmr" typeface="MoolBoran"/>
+        <a:font script="Knda" typeface="Tunga"/>
+        <a:font script="Guru" typeface="Raavi"/>
+        <a:font script="Cans" typeface="Euphemia"/>
+        <a:font script="Cher" typeface="Plantagenet Cherokee"/>
+        <a:font script="Yiii" typeface="Microsoft Yi Baiti"/>
+        <a:font script="Tibt" typeface="Microsoft Himalaya"/>
+        <a:font script="Thaa" typeface="MV Boli"/>
+        <a:font script="Deva" typeface="Mangal"/>
+        <a:font script="Telu" typeface="Gautami"/>
+        <a:font script="Taml" typeface="Latha"/>
+        <a:font script="Syrc" typeface="Estrangelo Edessa"/>
+        <a:font script="Orya" typeface="Kalinga"/>
+        <a:font script="Mlym" typeface="Kartika"/>
+        <a:font script="Laoo" typeface="DokChampa"/>
+        <a:font script="Sinh" typeface="Iskoola Pota"/>
+        <a:font script="Mong" typeface="Mongolian Baiti"/>
+        <a:font script="Viet" typeface="Arial"/>
+        <a:font script="Uigh" typeface="Microsoft Uighur"/>
+        <a:font script="Geor" typeface="Sylfaen"/>
+        <a:font script="Armn" typeface="Arial"/>
+        <a:font script="Bugi" typeface="Leelawadee UI"/>
+        <a:font script="Bopo" typeface="Microsoft JhengHei"/>
+        <a:font script="Java" typeface="Javanese Text"/>
+        <a:font script="Lisu" typeface="Segoe UI"/>
+        <a:font script="Mymr" typeface="Myanmar Text"/>
+        <a:font script="Nkoo" typeface="Ebrima"/>
+        <a:font script="Olck" typeface="Nirmala UI"/>
+        <a:font script="Osma" typeface="Ebrima"/>
+        <a:font script="Phag" typeface="Phagspa"/>
+        <a:font script="Syrn" typeface="Estrangelo Edessa"/>
+        <a:font script="Syrj" typeface="Estrangelo Edessa"/>
+        <a:font script="Syre" typeface="Estrangelo Edessa"/>
+        <a:font script="Sora" typeface="Nirmala UI"/>
+        <a:font script="Tale" typeface="Microsoft Tai Le"/>
+        <a:font script="Talu" typeface="Microsoft New Tai Lue"/>
+        <a:font script="Tfng" typeface="Ebrima"/>
       </a:minorFont>
     </a:fontScheme>
     <a:fmtScheme name="Office">

</xml_diff>